<commit_message>
Remove PPTX and DOCX files from GitHub repository
</commit_message>
<xml_diff>
--- a/Samsung_PRISM_Generative_AI_Hackathon_Presentation.pptx
+++ b/Samsung_PRISM_Generative_AI_Hackathon_Presentation.pptx
@@ -5,20 +5,20 @@
     <p:sldMasterId id="2147483648" r:id="rId1"/>
   </p:sldMasterIdLst>
   <p:sldIdLst>
-    <p:sldId id="256" r:id="rId7"/>
-    <p:sldId id="257" r:id="rId8"/>
-    <p:sldId id="258" r:id="rId9"/>
-    <p:sldId id="259" r:id="rId10"/>
-    <p:sldId id="260" r:id="rId11"/>
-    <p:sldId id="261" r:id="rId12"/>
-    <p:sldId id="262" r:id="rId13"/>
-    <p:sldId id="263" r:id="rId14"/>
-    <p:sldId id="264" r:id="rId15"/>
-    <p:sldId id="265" r:id="rId16"/>
-    <p:sldId id="266" r:id="rId17"/>
-    <p:sldId id="267" r:id="rId18"/>
+    <p:sldId id="256" r:id="rId2"/>
+    <p:sldId id="257" r:id="rId3"/>
+    <p:sldId id="258" r:id="rId4"/>
+    <p:sldId id="259" r:id="rId5"/>
+    <p:sldId id="260" r:id="rId6"/>
+    <p:sldId id="261" r:id="rId7"/>
+    <p:sldId id="262" r:id="rId8"/>
+    <p:sldId id="263" r:id="rId9"/>
+    <p:sldId id="264" r:id="rId10"/>
+    <p:sldId id="265" r:id="rId11"/>
+    <p:sldId id="266" r:id="rId12"/>
+    <p:sldId id="267" r:id="rId13"/>
   </p:sldIdLst>
-  <p:sldSz cx="12191695" cy="6858000" type="screen4x3"/>
+  <p:sldSz cx="12192000" cy="6858000"/>
   <p:notesSz cx="6858000" cy="9144000"/>
   <p:defaultTextStyle>
     <a:defPPr>
@@ -115,6 +115,22 @@
       </a:defRPr>
     </a:lvl9pPr>
   </p:defaultTextStyle>
+  <p:extLst>
+    <p:ext uri="{EFAFB233-063F-42B5-8137-9DF3F51BA10A}">
+      <p15:sldGuideLst xmlns:p15="http://schemas.microsoft.com/office/powerpoint/2012/main">
+        <p15:guide id="1" orient="horz" pos="2160">
+          <p15:clr>
+            <a:srgbClr val="A4A3A4"/>
+          </p15:clr>
+        </p15:guide>
+        <p15:guide id="2" pos="2880">
+          <p15:clr>
+            <a:srgbClr val="A4A3A4"/>
+          </p15:clr>
+        </p15:guide>
+      </p15:sldGuideLst>
+    </p:ext>
+  </p:extLst>
 </p:presentation>
 </file>
 
@@ -156,10 +172,9 @@
           <a:lstStyle/>
           <a:p>
             <a:r>
-              <a:rPr lang="en-US" smtClean="0"/>
+              <a:rPr lang="en-US"/>
               <a:t>Click to edit Master title style</a:t>
             </a:r>
-            <a:endParaRPr lang="en-US"/>
           </a:p>
         </p:txBody>
       </p:sp>
@@ -275,10 +290,9 @@
           </a:lstStyle>
           <a:p>
             <a:r>
-              <a:rPr lang="en-US" smtClean="0"/>
+              <a:rPr lang="en-US"/>
               <a:t>Click to edit Master subtitle style</a:t>
             </a:r>
-            <a:endParaRPr lang="en-US"/>
           </a:p>
         </p:txBody>
       </p:sp>
@@ -299,7 +313,7 @@
           <a:p>
             <a:fld id="{5BCAD085-E8A6-8845-BD4E-CB4CCA059FC4}" type="datetimeFigureOut">
               <a:rPr lang="en-US" smtClean="0"/>
-              <a:t>1/27/13</a:t>
+              <a:t>9/27/2026</a:t>
             </a:fld>
             <a:endParaRPr lang="en-US"/>
           </a:p>
@@ -393,10 +407,9 @@
           <a:lstStyle/>
           <a:p>
             <a:r>
-              <a:rPr lang="en-US" smtClean="0"/>
+              <a:rPr lang="en-US"/>
               <a:t>Click to edit Master title style</a:t>
             </a:r>
-            <a:endParaRPr lang="en-US"/>
           </a:p>
         </p:txBody>
       </p:sp>
@@ -417,38 +430,37 @@
           <a:p>
             <a:pPr lvl="0"/>
             <a:r>
-              <a:rPr lang="en-US" smtClean="0"/>
+              <a:rPr lang="en-US"/>
               <a:t>Click to edit Master text styles</a:t>
             </a:r>
           </a:p>
           <a:p>
             <a:pPr lvl="1"/>
             <a:r>
-              <a:rPr lang="en-US" smtClean="0"/>
+              <a:rPr lang="en-US"/>
               <a:t>Second level</a:t>
             </a:r>
           </a:p>
           <a:p>
             <a:pPr lvl="2"/>
             <a:r>
-              <a:rPr lang="en-US" smtClean="0"/>
+              <a:rPr lang="en-US"/>
               <a:t>Third level</a:t>
             </a:r>
           </a:p>
           <a:p>
             <a:pPr lvl="3"/>
             <a:r>
-              <a:rPr lang="en-US" smtClean="0"/>
+              <a:rPr lang="en-US"/>
               <a:t>Fourth level</a:t>
             </a:r>
           </a:p>
           <a:p>
             <a:pPr lvl="4"/>
             <a:r>
-              <a:rPr lang="en-US" smtClean="0"/>
+              <a:rPr lang="en-US"/>
               <a:t>Fifth level</a:t>
             </a:r>
-            <a:endParaRPr lang="en-US"/>
           </a:p>
         </p:txBody>
       </p:sp>
@@ -469,7 +481,7 @@
           <a:p>
             <a:fld id="{5BCAD085-E8A6-8845-BD4E-CB4CCA059FC4}" type="datetimeFigureOut">
               <a:rPr lang="en-US" smtClean="0"/>
-              <a:t>1/27/13</a:t>
+              <a:t>9/27/2026</a:t>
             </a:fld>
             <a:endParaRPr lang="en-US"/>
           </a:p>
@@ -568,10 +580,9 @@
           <a:lstStyle/>
           <a:p>
             <a:r>
-              <a:rPr lang="en-US" smtClean="0"/>
+              <a:rPr lang="en-US"/>
               <a:t>Click to edit Master title style</a:t>
             </a:r>
-            <a:endParaRPr lang="en-US"/>
           </a:p>
         </p:txBody>
       </p:sp>
@@ -597,38 +608,37 @@
           <a:p>
             <a:pPr lvl="0"/>
             <a:r>
-              <a:rPr lang="en-US" smtClean="0"/>
+              <a:rPr lang="en-US"/>
               <a:t>Click to edit Master text styles</a:t>
             </a:r>
           </a:p>
           <a:p>
             <a:pPr lvl="1"/>
             <a:r>
-              <a:rPr lang="en-US" smtClean="0"/>
+              <a:rPr lang="en-US"/>
               <a:t>Second level</a:t>
             </a:r>
           </a:p>
           <a:p>
             <a:pPr lvl="2"/>
             <a:r>
-              <a:rPr lang="en-US" smtClean="0"/>
+              <a:rPr lang="en-US"/>
               <a:t>Third level</a:t>
             </a:r>
           </a:p>
           <a:p>
             <a:pPr lvl="3"/>
             <a:r>
-              <a:rPr lang="en-US" smtClean="0"/>
+              <a:rPr lang="en-US"/>
               <a:t>Fourth level</a:t>
             </a:r>
           </a:p>
           <a:p>
             <a:pPr lvl="4"/>
             <a:r>
-              <a:rPr lang="en-US" smtClean="0"/>
+              <a:rPr lang="en-US"/>
               <a:t>Fifth level</a:t>
             </a:r>
-            <a:endParaRPr lang="en-US"/>
           </a:p>
         </p:txBody>
       </p:sp>
@@ -649,7 +659,7 @@
           <a:p>
             <a:fld id="{5BCAD085-E8A6-8845-BD4E-CB4CCA059FC4}" type="datetimeFigureOut">
               <a:rPr lang="en-US" smtClean="0"/>
-              <a:t>1/27/13</a:t>
+              <a:t>9/27/2026</a:t>
             </a:fld>
             <a:endParaRPr lang="en-US"/>
           </a:p>
@@ -743,10 +753,9 @@
           <a:lstStyle/>
           <a:p>
             <a:r>
-              <a:rPr lang="en-US" smtClean="0"/>
+              <a:rPr lang="en-US"/>
               <a:t>Click to edit Master title style</a:t>
             </a:r>
-            <a:endParaRPr lang="en-US"/>
           </a:p>
         </p:txBody>
       </p:sp>
@@ -767,38 +776,37 @@
           <a:p>
             <a:pPr lvl="0"/>
             <a:r>
-              <a:rPr lang="en-US" smtClean="0"/>
+              <a:rPr lang="en-US"/>
               <a:t>Click to edit Master text styles</a:t>
             </a:r>
           </a:p>
           <a:p>
             <a:pPr lvl="1"/>
             <a:r>
-              <a:rPr lang="en-US" smtClean="0"/>
+              <a:rPr lang="en-US"/>
               <a:t>Second level</a:t>
             </a:r>
           </a:p>
           <a:p>
             <a:pPr lvl="2"/>
             <a:r>
-              <a:rPr lang="en-US" smtClean="0"/>
+              <a:rPr lang="en-US"/>
               <a:t>Third level</a:t>
             </a:r>
           </a:p>
           <a:p>
             <a:pPr lvl="3"/>
             <a:r>
-              <a:rPr lang="en-US" smtClean="0"/>
+              <a:rPr lang="en-US"/>
               <a:t>Fourth level</a:t>
             </a:r>
           </a:p>
           <a:p>
             <a:pPr lvl="4"/>
             <a:r>
-              <a:rPr lang="en-US" smtClean="0"/>
+              <a:rPr lang="en-US"/>
               <a:t>Fifth level</a:t>
             </a:r>
-            <a:endParaRPr lang="en-US"/>
           </a:p>
         </p:txBody>
       </p:sp>
@@ -819,7 +827,7 @@
           <a:p>
             <a:fld id="{5BCAD085-E8A6-8845-BD4E-CB4CCA059FC4}" type="datetimeFigureOut">
               <a:rPr lang="en-US" smtClean="0"/>
-              <a:t>1/27/13</a:t>
+              <a:t>9/27/2026</a:t>
             </a:fld>
             <a:endParaRPr lang="en-US"/>
           </a:p>
@@ -922,10 +930,9 @@
           </a:lstStyle>
           <a:p>
             <a:r>
-              <a:rPr lang="en-US" smtClean="0"/>
+              <a:rPr lang="en-US"/>
               <a:t>Click to edit Master title style</a:t>
             </a:r>
-            <a:endParaRPr lang="en-US"/>
           </a:p>
         </p:txBody>
       </p:sp>
@@ -1042,7 +1049,7 @@
           <a:p>
             <a:pPr lvl="0"/>
             <a:r>
-              <a:rPr lang="en-US" smtClean="0"/>
+              <a:rPr lang="en-US"/>
               <a:t>Click to edit Master text styles</a:t>
             </a:r>
           </a:p>
@@ -1065,7 +1072,7 @@
           <a:p>
             <a:fld id="{5BCAD085-E8A6-8845-BD4E-CB4CCA059FC4}" type="datetimeFigureOut">
               <a:rPr lang="en-US" smtClean="0"/>
-              <a:t>1/27/13</a:t>
+              <a:t>9/27/2026</a:t>
             </a:fld>
             <a:endParaRPr lang="en-US"/>
           </a:p>
@@ -1159,10 +1166,9 @@
           <a:lstStyle/>
           <a:p>
             <a:r>
-              <a:rPr lang="en-US" smtClean="0"/>
+              <a:rPr lang="en-US"/>
               <a:t>Click to edit Master title style</a:t>
             </a:r>
-            <a:endParaRPr lang="en-US"/>
           </a:p>
         </p:txBody>
       </p:sp>
@@ -1216,38 +1222,37 @@
           <a:p>
             <a:pPr lvl="0"/>
             <a:r>
-              <a:rPr lang="en-US" smtClean="0"/>
+              <a:rPr lang="en-US"/>
               <a:t>Click to edit Master text styles</a:t>
             </a:r>
           </a:p>
           <a:p>
             <a:pPr lvl="1"/>
             <a:r>
-              <a:rPr lang="en-US" smtClean="0"/>
+              <a:rPr lang="en-US"/>
               <a:t>Second level</a:t>
             </a:r>
           </a:p>
           <a:p>
             <a:pPr lvl="2"/>
             <a:r>
-              <a:rPr lang="en-US" smtClean="0"/>
+              <a:rPr lang="en-US"/>
               <a:t>Third level</a:t>
             </a:r>
           </a:p>
           <a:p>
             <a:pPr lvl="3"/>
             <a:r>
-              <a:rPr lang="en-US" smtClean="0"/>
+              <a:rPr lang="en-US"/>
               <a:t>Fourth level</a:t>
             </a:r>
           </a:p>
           <a:p>
             <a:pPr lvl="4"/>
             <a:r>
-              <a:rPr lang="en-US" smtClean="0"/>
+              <a:rPr lang="en-US"/>
               <a:t>Fifth level</a:t>
             </a:r>
-            <a:endParaRPr lang="en-US"/>
           </a:p>
         </p:txBody>
       </p:sp>
@@ -1301,38 +1306,37 @@
           <a:p>
             <a:pPr lvl="0"/>
             <a:r>
-              <a:rPr lang="en-US" smtClean="0"/>
+              <a:rPr lang="en-US"/>
               <a:t>Click to edit Master text styles</a:t>
             </a:r>
           </a:p>
           <a:p>
             <a:pPr lvl="1"/>
             <a:r>
-              <a:rPr lang="en-US" smtClean="0"/>
+              <a:rPr lang="en-US"/>
               <a:t>Second level</a:t>
             </a:r>
           </a:p>
           <a:p>
             <a:pPr lvl="2"/>
             <a:r>
-              <a:rPr lang="en-US" smtClean="0"/>
+              <a:rPr lang="en-US"/>
               <a:t>Third level</a:t>
             </a:r>
           </a:p>
           <a:p>
             <a:pPr lvl="3"/>
             <a:r>
-              <a:rPr lang="en-US" smtClean="0"/>
+              <a:rPr lang="en-US"/>
               <a:t>Fourth level</a:t>
             </a:r>
           </a:p>
           <a:p>
             <a:pPr lvl="4"/>
             <a:r>
-              <a:rPr lang="en-US" smtClean="0"/>
+              <a:rPr lang="en-US"/>
               <a:t>Fifth level</a:t>
             </a:r>
-            <a:endParaRPr lang="en-US"/>
           </a:p>
         </p:txBody>
       </p:sp>
@@ -1353,7 +1357,7 @@
           <a:p>
             <a:fld id="{5BCAD085-E8A6-8845-BD4E-CB4CCA059FC4}" type="datetimeFigureOut">
               <a:rPr lang="en-US" smtClean="0"/>
-              <a:t>1/27/13</a:t>
+              <a:t>9/27/2026</a:t>
             </a:fld>
             <a:endParaRPr lang="en-US"/>
           </a:p>
@@ -1451,10 +1455,9 @@
           </a:lstStyle>
           <a:p>
             <a:r>
-              <a:rPr lang="en-US" smtClean="0"/>
+              <a:rPr lang="en-US"/>
               <a:t>Click to edit Master title style</a:t>
             </a:r>
-            <a:endParaRPr lang="en-US"/>
           </a:p>
         </p:txBody>
       </p:sp>
@@ -1517,7 +1520,7 @@
           <a:p>
             <a:pPr lvl="0"/>
             <a:r>
-              <a:rPr lang="en-US" smtClean="0"/>
+              <a:rPr lang="en-US"/>
               <a:t>Click to edit Master text styles</a:t>
             </a:r>
           </a:p>
@@ -1573,38 +1576,37 @@
           <a:p>
             <a:pPr lvl="0"/>
             <a:r>
-              <a:rPr lang="en-US" smtClean="0"/>
+              <a:rPr lang="en-US"/>
               <a:t>Click to edit Master text styles</a:t>
             </a:r>
           </a:p>
           <a:p>
             <a:pPr lvl="1"/>
             <a:r>
-              <a:rPr lang="en-US" smtClean="0"/>
+              <a:rPr lang="en-US"/>
               <a:t>Second level</a:t>
             </a:r>
           </a:p>
           <a:p>
             <a:pPr lvl="2"/>
             <a:r>
-              <a:rPr lang="en-US" smtClean="0"/>
+              <a:rPr lang="en-US"/>
               <a:t>Third level</a:t>
             </a:r>
           </a:p>
           <a:p>
             <a:pPr lvl="3"/>
             <a:r>
-              <a:rPr lang="en-US" smtClean="0"/>
+              <a:rPr lang="en-US"/>
               <a:t>Fourth level</a:t>
             </a:r>
           </a:p>
           <a:p>
             <a:pPr lvl="4"/>
             <a:r>
-              <a:rPr lang="en-US" smtClean="0"/>
+              <a:rPr lang="en-US"/>
               <a:t>Fifth level</a:t>
             </a:r>
-            <a:endParaRPr lang="en-US"/>
           </a:p>
         </p:txBody>
       </p:sp>
@@ -1667,7 +1669,7 @@
           <a:p>
             <a:pPr lvl="0"/>
             <a:r>
-              <a:rPr lang="en-US" smtClean="0"/>
+              <a:rPr lang="en-US"/>
               <a:t>Click to edit Master text styles</a:t>
             </a:r>
           </a:p>
@@ -1723,38 +1725,37 @@
           <a:p>
             <a:pPr lvl="0"/>
             <a:r>
-              <a:rPr lang="en-US" smtClean="0"/>
+              <a:rPr lang="en-US"/>
               <a:t>Click to edit Master text styles</a:t>
             </a:r>
           </a:p>
           <a:p>
             <a:pPr lvl="1"/>
             <a:r>
-              <a:rPr lang="en-US" smtClean="0"/>
+              <a:rPr lang="en-US"/>
               <a:t>Second level</a:t>
             </a:r>
           </a:p>
           <a:p>
             <a:pPr lvl="2"/>
             <a:r>
-              <a:rPr lang="en-US" smtClean="0"/>
+              <a:rPr lang="en-US"/>
               <a:t>Third level</a:t>
             </a:r>
           </a:p>
           <a:p>
             <a:pPr lvl="3"/>
             <a:r>
-              <a:rPr lang="en-US" smtClean="0"/>
+              <a:rPr lang="en-US"/>
               <a:t>Fourth level</a:t>
             </a:r>
           </a:p>
           <a:p>
             <a:pPr lvl="4"/>
             <a:r>
-              <a:rPr lang="en-US" smtClean="0"/>
+              <a:rPr lang="en-US"/>
               <a:t>Fifth level</a:t>
             </a:r>
-            <a:endParaRPr lang="en-US"/>
           </a:p>
         </p:txBody>
       </p:sp>
@@ -1775,7 +1776,7 @@
           <a:p>
             <a:fld id="{5BCAD085-E8A6-8845-BD4E-CB4CCA059FC4}" type="datetimeFigureOut">
               <a:rPr lang="en-US" smtClean="0"/>
-              <a:t>1/27/13</a:t>
+              <a:t>9/27/2026</a:t>
             </a:fld>
             <a:endParaRPr lang="en-US"/>
           </a:p>
@@ -1869,10 +1870,9 @@
           <a:lstStyle/>
           <a:p>
             <a:r>
-              <a:rPr lang="en-US" smtClean="0"/>
+              <a:rPr lang="en-US"/>
               <a:t>Click to edit Master title style</a:t>
             </a:r>
-            <a:endParaRPr lang="en-US"/>
           </a:p>
         </p:txBody>
       </p:sp>
@@ -1893,7 +1893,7 @@
           <a:p>
             <a:fld id="{5BCAD085-E8A6-8845-BD4E-CB4CCA059FC4}" type="datetimeFigureOut">
               <a:rPr lang="en-US" smtClean="0"/>
-              <a:t>1/27/13</a:t>
+              <a:t>9/27/2026</a:t>
             </a:fld>
             <a:endParaRPr lang="en-US"/>
           </a:p>
@@ -1988,7 +1988,7 @@
           <a:p>
             <a:fld id="{5BCAD085-E8A6-8845-BD4E-CB4CCA059FC4}" type="datetimeFigureOut">
               <a:rPr lang="en-US" smtClean="0"/>
-              <a:t>1/27/13</a:t>
+              <a:t>9/27/2026</a:t>
             </a:fld>
             <a:endParaRPr lang="en-US"/>
           </a:p>
@@ -2091,10 +2091,9 @@
           </a:lstStyle>
           <a:p>
             <a:r>
-              <a:rPr lang="en-US" smtClean="0"/>
+              <a:rPr lang="en-US"/>
               <a:t>Click to edit Master title style</a:t>
             </a:r>
-            <a:endParaRPr lang="en-US"/>
           </a:p>
         </p:txBody>
       </p:sp>
@@ -2148,38 +2147,37 @@
           <a:p>
             <a:pPr lvl="0"/>
             <a:r>
-              <a:rPr lang="en-US" smtClean="0"/>
+              <a:rPr lang="en-US"/>
               <a:t>Click to edit Master text styles</a:t>
             </a:r>
           </a:p>
           <a:p>
             <a:pPr lvl="1"/>
             <a:r>
-              <a:rPr lang="en-US" smtClean="0"/>
+              <a:rPr lang="en-US"/>
               <a:t>Second level</a:t>
             </a:r>
           </a:p>
           <a:p>
             <a:pPr lvl="2"/>
             <a:r>
-              <a:rPr lang="en-US" smtClean="0"/>
+              <a:rPr lang="en-US"/>
               <a:t>Third level</a:t>
             </a:r>
           </a:p>
           <a:p>
             <a:pPr lvl="3"/>
             <a:r>
-              <a:rPr lang="en-US" smtClean="0"/>
+              <a:rPr lang="en-US"/>
               <a:t>Fourth level</a:t>
             </a:r>
           </a:p>
           <a:p>
             <a:pPr lvl="4"/>
             <a:r>
-              <a:rPr lang="en-US" smtClean="0"/>
+              <a:rPr lang="en-US"/>
               <a:t>Fifth level</a:t>
             </a:r>
-            <a:endParaRPr lang="en-US"/>
           </a:p>
         </p:txBody>
       </p:sp>
@@ -2242,7 +2240,7 @@
           <a:p>
             <a:pPr lvl="0"/>
             <a:r>
-              <a:rPr lang="en-US" smtClean="0"/>
+              <a:rPr lang="en-US"/>
               <a:t>Click to edit Master text styles</a:t>
             </a:r>
           </a:p>
@@ -2265,7 +2263,7 @@
           <a:p>
             <a:fld id="{5BCAD085-E8A6-8845-BD4E-CB4CCA059FC4}" type="datetimeFigureOut">
               <a:rPr lang="en-US" smtClean="0"/>
-              <a:t>1/27/13</a:t>
+              <a:t>9/27/2026</a:t>
             </a:fld>
             <a:endParaRPr lang="en-US"/>
           </a:p>
@@ -2368,10 +2366,9 @@
           </a:lstStyle>
           <a:p>
             <a:r>
-              <a:rPr lang="en-US" smtClean="0"/>
+              <a:rPr lang="en-US"/>
               <a:t>Click to edit Master title style</a:t>
             </a:r>
-            <a:endParaRPr lang="en-US"/>
           </a:p>
         </p:txBody>
       </p:sp>
@@ -2495,7 +2492,7 @@
           <a:p>
             <a:pPr lvl="0"/>
             <a:r>
-              <a:rPr lang="en-US" smtClean="0"/>
+              <a:rPr lang="en-US"/>
               <a:t>Click to edit Master text styles</a:t>
             </a:r>
           </a:p>
@@ -2518,7 +2515,7 @@
           <a:p>
             <a:fld id="{5BCAD085-E8A6-8845-BD4E-CB4CCA059FC4}" type="datetimeFigureOut">
               <a:rPr lang="en-US" smtClean="0"/>
-              <a:t>1/27/13</a:t>
+              <a:t>9/27/2026</a:t>
             </a:fld>
             <a:endParaRPr lang="en-US"/>
           </a:p>
@@ -2627,10 +2624,9 @@
           <a:lstStyle/>
           <a:p>
             <a:r>
-              <a:rPr lang="en-US" smtClean="0"/>
+              <a:rPr lang="en-US"/>
               <a:t>Click to edit Master title style</a:t>
             </a:r>
-            <a:endParaRPr lang="en-US"/>
           </a:p>
         </p:txBody>
       </p:sp>
@@ -2661,38 +2657,37 @@
           <a:p>
             <a:pPr lvl="0"/>
             <a:r>
-              <a:rPr lang="en-US" smtClean="0"/>
+              <a:rPr lang="en-US"/>
               <a:t>Click to edit Master text styles</a:t>
             </a:r>
           </a:p>
           <a:p>
             <a:pPr lvl="1"/>
             <a:r>
-              <a:rPr lang="en-US" smtClean="0"/>
+              <a:rPr lang="en-US"/>
               <a:t>Second level</a:t>
             </a:r>
           </a:p>
           <a:p>
             <a:pPr lvl="2"/>
             <a:r>
-              <a:rPr lang="en-US" smtClean="0"/>
+              <a:rPr lang="en-US"/>
               <a:t>Third level</a:t>
             </a:r>
           </a:p>
           <a:p>
             <a:pPr lvl="3"/>
             <a:r>
-              <a:rPr lang="en-US" smtClean="0"/>
+              <a:rPr lang="en-US"/>
               <a:t>Fourth level</a:t>
             </a:r>
           </a:p>
           <a:p>
             <a:pPr lvl="4"/>
             <a:r>
-              <a:rPr lang="en-US" smtClean="0"/>
+              <a:rPr lang="en-US"/>
               <a:t>Fifth level</a:t>
             </a:r>
-            <a:endParaRPr lang="en-US"/>
           </a:p>
         </p:txBody>
       </p:sp>
@@ -2731,7 +2726,7 @@
           <a:p>
             <a:fld id="{5BCAD085-E8A6-8845-BD4E-CB4CCA059FC4}" type="datetimeFigureOut">
               <a:rPr lang="en-US" smtClean="0"/>
-              <a:t>1/27/13</a:t>
+              <a:t>9/27/2026</a:t>
             </a:fld>
             <a:endParaRPr lang="en-US"/>
           </a:p>
@@ -3090,7 +3085,7 @@
 </file>
 
 <file path=ppt/slides/slide1.xml><?xml version="1.0" encoding="utf-8"?>
-<p:sld xmlns:a="http://schemas.openxmlformats.org/drawingml/2006/main" xmlns:p="http://schemas.openxmlformats.org/presentationml/2006/main" xmlns:r="http://schemas.openxmlformats.org/officeDocument/2006/relationships">
+<p:sld xmlns:a="http://schemas.openxmlformats.org/drawingml/2006/main" xmlns:r="http://schemas.openxmlformats.org/officeDocument/2006/relationships" xmlns:p="http://schemas.openxmlformats.org/presentationml/2006/main">
   <p:cSld>
     <p:spTree>
       <p:nvGrpSpPr>
@@ -3098,7 +3093,14 @@
         <p:cNvGrpSpPr/>
         <p:nvPr/>
       </p:nvGrpSpPr>
-      <p:grpSpPr/>
+      <p:grpSpPr>
+        <a:xfrm>
+          <a:off x="0" y="0"/>
+          <a:ext cx="0" cy="0"/>
+          <a:chOff x="0" y="0"/>
+          <a:chExt cx="0" cy="0"/>
+        </a:xfrm>
+      </p:grpSpPr>
       <p:sp>
         <p:nvSpPr>
           <p:cNvPr id="2" name="Rectangle 1"/>
@@ -3139,6 +3141,7 @@
           <a:lstStyle/>
           <a:p>
             <a:pPr algn="ctr"/>
+            <a:endParaRPr/>
           </a:p>
         </p:txBody>
       </p:sp>
@@ -3278,7 +3281,7 @@
         <p:spPr>
           <a:xfrm>
             <a:off x="731520" y="3474720"/>
-            <a:ext cx="10515600" cy="2926080"/>
+            <a:ext cx="10515600" cy="2246769"/>
           </a:xfrm>
           <a:prstGeom prst="rect">
             <a:avLst/>
@@ -3299,8 +3302,14 @@
               </a:defRPr>
             </a:pPr>
             <a:r>
-              <a:t>• Theme ID - [To be filled]</a:t>
-            </a:r>
+              <a:rPr sz="2000" dirty="0"/>
+              <a:t>• Theme ID - </a:t>
+            </a:r>
+            <a:r>
+              <a:rPr lang="en-US" sz="2000" dirty="0"/>
+              <a:t>1</a:t>
+            </a:r>
+            <a:endParaRPr sz="2000" dirty="0"/>
           </a:p>
           <a:p>
             <a:pPr>
@@ -3311,8 +3320,22 @@
               </a:defRPr>
             </a:pPr>
             <a:r>
-              <a:t>• Team Name - [To be filled]</a:t>
-            </a:r>
+              <a:rPr sz="2000" dirty="0"/>
+              <a:t>• Team Name </a:t>
+            </a:r>
+            <a:r>
+              <a:rPr lang="en-US" sz="2000" dirty="0"/>
+              <a:t>–</a:t>
+            </a:r>
+            <a:r>
+              <a:rPr sz="2000" dirty="0"/>
+              <a:t> </a:t>
+            </a:r>
+            <a:r>
+              <a:rPr lang="en-US" sz="2000" dirty="0"/>
+              <a:t>unsorted bits</a:t>
+            </a:r>
+            <a:endParaRPr sz="2000" dirty="0"/>
           </a:p>
           <a:p>
             <a:pPr>
@@ -3323,8 +3346,22 @@
               </a:defRPr>
             </a:pPr>
             <a:r>
-              <a:t>• College Name - [To be filled]</a:t>
-            </a:r>
+              <a:rPr sz="2000" dirty="0"/>
+              <a:t>• College Name </a:t>
+            </a:r>
+            <a:r>
+              <a:rPr lang="en-US" sz="2000" dirty="0"/>
+              <a:t>–</a:t>
+            </a:r>
+            <a:r>
+              <a:rPr sz="2000" dirty="0"/>
+              <a:t> </a:t>
+            </a:r>
+            <a:r>
+              <a:rPr lang="en-US" sz="2000" dirty="0"/>
+              <a:t>Vellore Institute of technology</a:t>
+            </a:r>
+            <a:endParaRPr sz="2000" dirty="0"/>
           </a:p>
           <a:p>
             <a:pPr>
@@ -3335,8 +3372,22 @@
               </a:defRPr>
             </a:pPr>
             <a:r>
-              <a:t>• Member Name &amp; Email 1 - [To be filled]</a:t>
-            </a:r>
+              <a:rPr sz="2000" dirty="0"/>
+              <a:t>• Member Name &amp; Email 1 </a:t>
+            </a:r>
+            <a:r>
+              <a:rPr lang="en-US" sz="2000" dirty="0"/>
+              <a:t>–</a:t>
+            </a:r>
+            <a:r>
+              <a:rPr sz="2000" dirty="0"/>
+              <a:t> </a:t>
+            </a:r>
+            <a:r>
+              <a:rPr lang="en-US" sz="2000" dirty="0"/>
+              <a:t>Adharsh Arvinth &amp; adharsharvinth2108@gmail.com</a:t>
+            </a:r>
+            <a:endParaRPr sz="2000" dirty="0"/>
           </a:p>
           <a:p>
             <a:pPr>
@@ -3347,8 +3398,22 @@
               </a:defRPr>
             </a:pPr>
             <a:r>
-              <a:t>• Member Name &amp; Email 2 - [To be filled]</a:t>
-            </a:r>
+              <a:rPr sz="2000" dirty="0"/>
+              <a:t>• Member Name &amp; Email 2 </a:t>
+            </a:r>
+            <a:r>
+              <a:rPr lang="en-US" sz="2000" dirty="0"/>
+              <a:t>–</a:t>
+            </a:r>
+            <a:r>
+              <a:rPr sz="2000" dirty="0"/>
+              <a:t> </a:t>
+            </a:r>
+            <a:r>
+              <a:rPr lang="en-US" sz="2000" dirty="0"/>
+              <a:t>Rahul J &amp; jrahulnaidu@gmail.com</a:t>
+            </a:r>
+            <a:endParaRPr sz="2000" dirty="0"/>
           </a:p>
           <a:p>
             <a:pPr>
@@ -3359,8 +3424,22 @@
               </a:defRPr>
             </a:pPr>
             <a:r>
-              <a:t>• Member Name &amp; Email 3 - [To be filled]</a:t>
-            </a:r>
+              <a:rPr sz="2000" dirty="0"/>
+              <a:t>• Member Name &amp; Email 3 </a:t>
+            </a:r>
+            <a:r>
+              <a:rPr lang="en-US" sz="2000" dirty="0"/>
+              <a:t>–</a:t>
+            </a:r>
+            <a:r>
+              <a:rPr sz="2000" dirty="0"/>
+              <a:t> </a:t>
+            </a:r>
+            <a:r>
+              <a:rPr lang="en-US" sz="2000" dirty="0"/>
+              <a:t>Sivamiruthula &amp; sivamiruthula3@gmail.com</a:t>
+            </a:r>
+            <a:endParaRPr sz="2000" dirty="0"/>
           </a:p>
           <a:p>
             <a:pPr>
@@ -3371,20 +3450,30 @@
               </a:defRPr>
             </a:pPr>
             <a:r>
-              <a:t>• Member Name &amp; Email 4 - [To be filled]</a:t>
-            </a:r>
-          </a:p>
-          <a:p>
-            <a:pPr>
-              <a:defRPr sz="1300">
-                <a:solidFill>
-                  <a:srgbClr val="1E1E2D"/>
-                </a:solidFill>
-              </a:defRPr>
-            </a:pPr>
-            <a:r>
-              <a:t>• Submission Github link - https://github.com/Adharsh-Arvinth/agentic-code-intelligence.git</a:t>
-            </a:r>
+              <a:rPr sz="2000" dirty="0"/>
+              <a:t>• Submission </a:t>
+            </a:r>
+            <a:r>
+              <a:rPr sz="2000" dirty="0" err="1"/>
+              <a:t>Github</a:t>
+            </a:r>
+            <a:r>
+              <a:rPr sz="2000" dirty="0"/>
+              <a:t> link -</a:t>
+            </a:r>
+            <a:r>
+              <a:rPr lang="en-US" sz="2000" dirty="0">
+                <a:hlinkClick r:id="rId2"/>
+              </a:rPr>
+              <a:t>https://github.com/Adharsh-Arvinth/agentic-code-</a:t>
+            </a:r>
+            <a:r>
+              <a:rPr lang="en-US" sz="2000" dirty="0" err="1">
+                <a:hlinkClick r:id="rId2"/>
+              </a:rPr>
+              <a:t>intelligence.git</a:t>
+            </a:r>
+            <a:endParaRPr sz="2000" dirty="0"/>
           </a:p>
         </p:txBody>
       </p:sp>
@@ -3397,7 +3486,7 @@
 </file>
 
 <file path=ppt/slides/slide10.xml><?xml version="1.0" encoding="utf-8"?>
-<p:sld xmlns:a="http://schemas.openxmlformats.org/drawingml/2006/main" xmlns:p="http://schemas.openxmlformats.org/presentationml/2006/main" xmlns:r="http://schemas.openxmlformats.org/officeDocument/2006/relationships">
+<p:sld xmlns:a="http://schemas.openxmlformats.org/drawingml/2006/main" xmlns:r="http://schemas.openxmlformats.org/officeDocument/2006/relationships" xmlns:p="http://schemas.openxmlformats.org/presentationml/2006/main">
   <p:cSld>
     <p:spTree>
       <p:nvGrpSpPr>
@@ -3405,7 +3494,14 @@
         <p:cNvGrpSpPr/>
         <p:nvPr/>
       </p:nvGrpSpPr>
-      <p:grpSpPr/>
+      <p:grpSpPr>
+        <a:xfrm>
+          <a:off x="0" y="0"/>
+          <a:ext cx="0" cy="0"/>
+          <a:chOff x="0" y="0"/>
+          <a:chExt cx="0" cy="0"/>
+        </a:xfrm>
+      </p:grpSpPr>
       <p:sp>
         <p:nvSpPr>
           <p:cNvPr id="2" name="Rectangle 1"/>
@@ -3446,6 +3542,7 @@
           <a:lstStyle/>
           <a:p>
             <a:pPr algn="ctr"/>
+            <a:endParaRPr/>
           </a:p>
         </p:txBody>
       </p:sp>
@@ -3494,7 +3591,7 @@
         <p:spPr>
           <a:xfrm>
             <a:off x="731520" y="1463040"/>
-            <a:ext cx="10728655" cy="4754880"/>
+            <a:ext cx="10728655" cy="4708981"/>
           </a:xfrm>
           <a:prstGeom prst="rect">
             <a:avLst/>
@@ -3515,6 +3612,7 @@
               </a:defRPr>
             </a:pPr>
             <a:r>
+              <a:rPr sz="2000" dirty="0"/>
               <a:t>1. Zero-GPU Hardware Requirement</a:t>
             </a:r>
           </a:p>
@@ -3527,9 +3625,13 @@
               </a:defRPr>
             </a:pPr>
             <a:r>
+              <a:rPr sz="2000" dirty="0"/>
               <a:t>The entire retrieval, indexing, and ranking pipeline runs on standard CPU hardware with zero CUDA dependency.</a:t>
             </a:r>
-            <a:br/>
+            <a:br>
+              <a:rPr sz="2000" dirty="0"/>
+            </a:br>
+            <a:endParaRPr sz="2000" dirty="0"/>
           </a:p>
           <a:p>
             <a:pPr>
@@ -3540,6 +3642,7 @@
               </a:defRPr>
             </a:pPr>
             <a:r>
+              <a:rPr sz="2000" dirty="0"/>
               <a:t>2. Version-Aware Index Management (P1 Goal)</a:t>
             </a:r>
           </a:p>
@@ -3552,9 +3655,13 @@
               </a:defRPr>
             </a:pPr>
             <a:r>
+              <a:rPr sz="2000" dirty="0"/>
               <a:t>Built-in support for registering, indexing, isolating, and searching specific code version tags (`--version v1.0`).</a:t>
             </a:r>
-            <a:br/>
+            <a:br>
+              <a:rPr sz="2000" dirty="0"/>
+            </a:br>
+            <a:endParaRPr sz="2000" dirty="0"/>
           </a:p>
           <a:p>
             <a:pPr>
@@ -3565,6 +3672,7 @@
               </a:defRPr>
             </a:pPr>
             <a:r>
+              <a:rPr sz="2000" dirty="0"/>
               <a:t>3. Official MTEB Framework Compliance</a:t>
             </a:r>
           </a:p>
@@ -3577,9 +3685,13 @@
               </a:defRPr>
             </a:pPr>
             <a:r>
+              <a:rPr sz="2000" dirty="0"/>
               <a:t>100% compliant with MTEB 2.x evaluation standards with automatic JSON results generation.</a:t>
             </a:r>
-            <a:br/>
+            <a:br>
+              <a:rPr sz="2000" dirty="0"/>
+            </a:br>
+            <a:endParaRPr sz="2000" dirty="0"/>
           </a:p>
           <a:p>
             <a:pPr>
@@ -3590,6 +3702,7 @@
               </a:defRPr>
             </a:pPr>
             <a:r>
+              <a:rPr sz="2000" dirty="0"/>
               <a:t>4. Comprehensive Unit Test Suite</a:t>
             </a:r>
           </a:p>
@@ -3602,9 +3715,21 @@
               </a:defRPr>
             </a:pPr>
             <a:r>
-              <a:t>42 automated pytest test cases covering metrics, preprocessors, retrievers, and versioning with 100% pass rate.</a:t>
-            </a:r>
-            <a:br/>
+              <a:rPr sz="2000" dirty="0"/>
+              <a:t>42 automated </a:t>
+            </a:r>
+            <a:r>
+              <a:rPr sz="2000" dirty="0" err="1"/>
+              <a:t>pytest</a:t>
+            </a:r>
+            <a:r>
+              <a:rPr sz="2000" dirty="0"/>
+              <a:t> test cases covering metrics, preprocessors, retrievers, and versioning with 100% pass rate.</a:t>
+            </a:r>
+            <a:br>
+              <a:rPr sz="2000" dirty="0"/>
+            </a:br>
+            <a:endParaRPr sz="2000" dirty="0"/>
           </a:p>
         </p:txBody>
       </p:sp>
@@ -3617,7 +3742,7 @@
 </file>
 
 <file path=ppt/slides/slide11.xml><?xml version="1.0" encoding="utf-8"?>
-<p:sld xmlns:a="http://schemas.openxmlformats.org/drawingml/2006/main" xmlns:p="http://schemas.openxmlformats.org/presentationml/2006/main" xmlns:r="http://schemas.openxmlformats.org/officeDocument/2006/relationships">
+<p:sld xmlns:a="http://schemas.openxmlformats.org/drawingml/2006/main" xmlns:r="http://schemas.openxmlformats.org/officeDocument/2006/relationships" xmlns:p="http://schemas.openxmlformats.org/presentationml/2006/main">
   <p:cSld>
     <p:spTree>
       <p:nvGrpSpPr>
@@ -3625,7 +3750,14 @@
         <p:cNvGrpSpPr/>
         <p:nvPr/>
       </p:nvGrpSpPr>
-      <p:grpSpPr/>
+      <p:grpSpPr>
+        <a:xfrm>
+          <a:off x="0" y="0"/>
+          <a:ext cx="0" cy="0"/>
+          <a:chOff x="0" y="0"/>
+          <a:chExt cx="0" cy="0"/>
+        </a:xfrm>
+      </p:grpSpPr>
       <p:sp>
         <p:nvSpPr>
           <p:cNvPr id="2" name="Rectangle 1"/>
@@ -3666,6 +3798,7 @@
           <a:lstStyle/>
           <a:p>
             <a:pPr algn="ctr"/>
+            <a:endParaRPr/>
           </a:p>
         </p:txBody>
       </p:sp>
@@ -3726,7 +3859,9 @@
             <a:spAutoFit/>
           </a:bodyPr>
           <a:lstStyle/>
-          <a:p/>
+          <a:p>
+            <a:endParaRPr/>
+          </a:p>
         </p:txBody>
       </p:sp>
       <p:sp>
@@ -3738,7 +3873,7 @@
         <p:spPr>
           <a:xfrm>
             <a:off x="731520" y="1463040"/>
-            <a:ext cx="10728655" cy="4754880"/>
+            <a:ext cx="10728655" cy="2308324"/>
           </a:xfrm>
           <a:prstGeom prst="rect">
             <a:avLst/>
@@ -3759,9 +3894,23 @@
               </a:defRPr>
             </a:pPr>
             <a:r>
-              <a:t>• Working prototype code — public or shared GitHub repo (Y/N): YES (https://github.com/Adharsh-Arvinth/agentic-code-intelligence.git)</a:t>
-            </a:r>
-            <a:br/>
+              <a:rPr dirty="0"/>
+              <a:t>• Working prototype code — public or shared GitHub repo (Y/N): YES (</a:t>
+            </a:r>
+            <a:r>
+              <a:rPr dirty="0">
+                <a:hlinkClick r:id="rId2"/>
+              </a:rPr>
+              <a:t>https://github.com/Adharsh-Arvinth/agentic-code-intelligence.git</a:t>
+            </a:r>
+            <a:r>
+              <a:rPr dirty="0"/>
+              <a:t>)</a:t>
+            </a:r>
+            <a:br>
+              <a:rPr dirty="0"/>
+            </a:br>
+            <a:endParaRPr dirty="0"/>
           </a:p>
           <a:p>
             <a:pPr>
@@ -3772,9 +3921,13 @@
               </a:defRPr>
             </a:pPr>
             <a:r>
+              <a:rPr dirty="0"/>
               <a:t>• README with reproducible setup instructions (Y/N): YES (Complete setup, CLI usage, &amp; benchmark reproduction steps)</a:t>
             </a:r>
-            <a:br/>
+            <a:br>
+              <a:rPr dirty="0"/>
+            </a:br>
+            <a:endParaRPr dirty="0"/>
           </a:p>
           <a:p>
             <a:pPr>
@@ -3785,9 +3938,13 @@
               </a:defRPr>
             </a:pPr>
             <a:r>
+              <a:rPr dirty="0"/>
               <a:t>• Demo video, max 5 minutes (YouTube or Drive link): [To be added by team]</a:t>
             </a:r>
-            <a:br/>
+            <a:br>
+              <a:rPr dirty="0"/>
+            </a:br>
+            <a:endParaRPr dirty="0"/>
           </a:p>
           <a:p>
             <a:pPr>
@@ -3798,9 +3955,13 @@
               </a:defRPr>
             </a:pPr>
             <a:r>
+              <a:rPr dirty="0"/>
               <a:t>• Presentation file (PPT or PDF) (Y/N): YES (This presentation deck)</a:t>
             </a:r>
-            <a:br/>
+            <a:br>
+              <a:rPr dirty="0"/>
+            </a:br>
+            <a:endParaRPr dirty="0"/>
           </a:p>
         </p:txBody>
       </p:sp>
@@ -3813,7 +3974,7 @@
 </file>
 
 <file path=ppt/slides/slide12.xml><?xml version="1.0" encoding="utf-8"?>
-<p:sld xmlns:a="http://schemas.openxmlformats.org/drawingml/2006/main" xmlns:p="http://schemas.openxmlformats.org/presentationml/2006/main" xmlns:r="http://schemas.openxmlformats.org/officeDocument/2006/relationships">
+<p:sld xmlns:a="http://schemas.openxmlformats.org/drawingml/2006/main" xmlns:r="http://schemas.openxmlformats.org/officeDocument/2006/relationships" xmlns:p="http://schemas.openxmlformats.org/presentationml/2006/main">
   <p:cSld>
     <p:spTree>
       <p:nvGrpSpPr>
@@ -3821,7 +3982,14 @@
         <p:cNvGrpSpPr/>
         <p:nvPr/>
       </p:nvGrpSpPr>
-      <p:grpSpPr/>
+      <p:grpSpPr>
+        <a:xfrm>
+          <a:off x="0" y="0"/>
+          <a:ext cx="0" cy="0"/>
+          <a:chOff x="0" y="0"/>
+          <a:chExt cx="0" cy="0"/>
+        </a:xfrm>
+      </p:grpSpPr>
       <p:sp>
         <p:nvSpPr>
           <p:cNvPr id="2" name="Rectangle 1"/>
@@ -3862,6 +4030,7 @@
           <a:lstStyle/>
           <a:p>
             <a:pPr algn="ctr"/>
+            <a:endParaRPr/>
           </a:p>
         </p:txBody>
       </p:sp>
@@ -3945,7 +4114,7 @@
 </file>
 
 <file path=ppt/slides/slide2.xml><?xml version="1.0" encoding="utf-8"?>
-<p:sld xmlns:a="http://schemas.openxmlformats.org/drawingml/2006/main" xmlns:p="http://schemas.openxmlformats.org/presentationml/2006/main" xmlns:r="http://schemas.openxmlformats.org/officeDocument/2006/relationships">
+<p:sld xmlns:a="http://schemas.openxmlformats.org/drawingml/2006/main" xmlns:r="http://schemas.openxmlformats.org/officeDocument/2006/relationships" xmlns:p="http://schemas.openxmlformats.org/presentationml/2006/main">
   <p:cSld>
     <p:spTree>
       <p:nvGrpSpPr>
@@ -3953,7 +4122,14 @@
         <p:cNvGrpSpPr/>
         <p:nvPr/>
       </p:nvGrpSpPr>
-      <p:grpSpPr/>
+      <p:grpSpPr>
+        <a:xfrm>
+          <a:off x="0" y="0"/>
+          <a:ext cx="0" cy="0"/>
+          <a:chOff x="0" y="0"/>
+          <a:chExt cx="0" cy="0"/>
+        </a:xfrm>
+      </p:grpSpPr>
       <p:sp>
         <p:nvSpPr>
           <p:cNvPr id="2" name="Rectangle 1"/>
@@ -3994,6 +4170,7 @@
           <a:lstStyle/>
           <a:p>
             <a:pPr algn="ctr"/>
+            <a:endParaRPr/>
           </a:p>
         </p:txBody>
       </p:sp>
@@ -4042,7 +4219,7 @@
         <p:spPr>
           <a:xfrm>
             <a:off x="731520" y="1463040"/>
-            <a:ext cx="10728655" cy="4754880"/>
+            <a:ext cx="10728655" cy="4647426"/>
           </a:xfrm>
           <a:prstGeom prst="rect">
             <a:avLst/>
@@ -4063,45 +4240,58 @@
               </a:defRPr>
             </a:pPr>
             <a:r>
-              <a:t>Theme: Code Intelligence &amp; Natural Language Text-to-Code Retrieval</a:t>
-            </a:r>
-          </a:p>
-          <a:p>
-            <a:br/>
-            <a:pPr>
-              <a:defRPr sz="1600">
-                <a:solidFill>
-                  <a:srgbClr val="646473"/>
-                </a:solidFill>
-              </a:defRPr>
-            </a:pPr>
-            <a:r>
+              <a:rPr sz="2800" dirty="0"/>
+              <a:t>Theme: </a:t>
+            </a:r>
+            <a:r>
+              <a:rPr lang="en-US" sz="2800" dirty="0"/>
+              <a:t>Agentic </a:t>
+            </a:r>
+            <a:r>
+              <a:rPr sz="2800" dirty="0"/>
+              <a:t>Code Intelligence &amp; Natural Language Text-to-Code Retrieval</a:t>
+            </a:r>
+          </a:p>
+          <a:p>
+            <a:br>
+              <a:rPr sz="2400" dirty="0"/>
+            </a:br>
+            <a:r>
+              <a:rPr sz="2400" dirty="0"/>
               <a:t>• Challenge Goal: Given a natural-language query describing algorithmic intent, retrieve and rank the most relevant Python code solutions from a large corpus of 8,765 snippets.</a:t>
             </a:r>
           </a:p>
           <a:p>
-            <a:br/>
-            <a:pPr>
-              <a:defRPr sz="1600">
-                <a:solidFill>
-                  <a:srgbClr val="646473"/>
-                </a:solidFill>
-              </a:defRPr>
-            </a:pPr>
-            <a:r>
-              <a:t>• Benchmark Focus: Target official CoIR AppsRetrieval benchmark evaluated on NDCG@10 and MRR@10.</a:t>
-            </a:r>
-          </a:p>
-          <a:p>
-            <a:br/>
-            <a:pPr>
-              <a:defRPr sz="1600">
-                <a:solidFill>
-                  <a:srgbClr val="646473"/>
-                </a:solidFill>
-              </a:defRPr>
-            </a:pPr>
-            <a:r>
+            <a:br>
+              <a:rPr sz="2400" dirty="0"/>
+            </a:br>
+            <a:r>
+              <a:rPr sz="2400" dirty="0"/>
+              <a:t>• Benchmark Focus: Target official </a:t>
+            </a:r>
+            <a:r>
+              <a:rPr sz="2400" dirty="0" err="1"/>
+              <a:t>CoIR</a:t>
+            </a:r>
+            <a:r>
+              <a:rPr sz="2400" dirty="0"/>
+              <a:t> </a:t>
+            </a:r>
+            <a:r>
+              <a:rPr sz="2400" dirty="0" err="1"/>
+              <a:t>AppsRetrieval</a:t>
+            </a:r>
+            <a:r>
+              <a:rPr sz="2400" dirty="0"/>
+              <a:t> benchmark evaluated on NDCG@10 and MRR@10.</a:t>
+            </a:r>
+          </a:p>
+          <a:p>
+            <a:br>
+              <a:rPr sz="2400" dirty="0"/>
+            </a:br>
+            <a:r>
+              <a:rPr sz="2400" dirty="0"/>
               <a:t>• Production Objective: Build a complete, CPU-optimized, version-aware hybrid code retrieval system ready for real-world developer tools and IDE integration.</a:t>
             </a:r>
           </a:p>
@@ -4116,7 +4306,7 @@
 </file>
 
 <file path=ppt/slides/slide3.xml><?xml version="1.0" encoding="utf-8"?>
-<p:sld xmlns:a="http://schemas.openxmlformats.org/drawingml/2006/main" xmlns:p="http://schemas.openxmlformats.org/presentationml/2006/main" xmlns:r="http://schemas.openxmlformats.org/officeDocument/2006/relationships">
+<p:sld xmlns:a="http://schemas.openxmlformats.org/drawingml/2006/main" xmlns:r="http://schemas.openxmlformats.org/officeDocument/2006/relationships" xmlns:p="http://schemas.openxmlformats.org/presentationml/2006/main">
   <p:cSld>
     <p:spTree>
       <p:nvGrpSpPr>
@@ -4124,7 +4314,14 @@
         <p:cNvGrpSpPr/>
         <p:nvPr/>
       </p:nvGrpSpPr>
-      <p:grpSpPr/>
+      <p:grpSpPr>
+        <a:xfrm>
+          <a:off x="0" y="0"/>
+          <a:ext cx="0" cy="0"/>
+          <a:chOff x="0" y="0"/>
+          <a:chExt cx="0" cy="0"/>
+        </a:xfrm>
+      </p:grpSpPr>
       <p:sp>
         <p:nvSpPr>
           <p:cNvPr id="2" name="Rectangle 1"/>
@@ -4165,6 +4362,7 @@
           <a:lstStyle/>
           <a:p>
             <a:pPr algn="ctr"/>
+            <a:endParaRPr/>
           </a:p>
         </p:txBody>
       </p:sp>
@@ -4213,7 +4411,7 @@
         <p:spPr>
           <a:xfrm>
             <a:off x="731520" y="1463040"/>
-            <a:ext cx="10728655" cy="4754880"/>
+            <a:ext cx="10728655" cy="4708981"/>
           </a:xfrm>
           <a:prstGeom prst="rect">
             <a:avLst/>
@@ -4234,6 +4432,7 @@
               </a:defRPr>
             </a:pPr>
             <a:r>
+              <a:rPr sz="2000" dirty="0"/>
               <a:t>1. Lexical-Only Search (BM25) Limitations</a:t>
             </a:r>
           </a:p>
@@ -4246,9 +4445,13 @@
               </a:defRPr>
             </a:pPr>
             <a:r>
+              <a:rPr sz="2000" dirty="0"/>
               <a:t>Fails when queries use conceptual natural language while solutions use domain-specific variable names or raw code syntax.</a:t>
             </a:r>
-            <a:br/>
+            <a:br>
+              <a:rPr sz="2000" dirty="0"/>
+            </a:br>
+            <a:endParaRPr sz="2000" dirty="0"/>
           </a:p>
           <a:p>
             <a:pPr>
@@ -4259,6 +4462,7 @@
               </a:defRPr>
             </a:pPr>
             <a:r>
+              <a:rPr sz="2000" dirty="0"/>
               <a:t>2. Dense-Only Vector Search Limitations</a:t>
             </a:r>
           </a:p>
@@ -4271,9 +4475,13 @@
               </a:defRPr>
             </a:pPr>
             <a:r>
+              <a:rPr sz="2000" dirty="0"/>
               <a:t>Misses exact technical identifier matches, function signatures, and explicit variable/import keywords.</a:t>
             </a:r>
-            <a:br/>
+            <a:br>
+              <a:rPr sz="2000" dirty="0"/>
+            </a:br>
+            <a:endParaRPr sz="2000" dirty="0"/>
           </a:p>
           <a:p>
             <a:pPr>
@@ -4284,8 +4492,14 @@
               </a:defRPr>
             </a:pPr>
             <a:r>
-              <a:t>3. High GPU Dependence of LLM Rerankers</a:t>
-            </a:r>
+              <a:rPr sz="2000" dirty="0"/>
+              <a:t>3. High GPU Dependence of LLM </a:t>
+            </a:r>
+            <a:r>
+              <a:rPr sz="2000" dirty="0" err="1"/>
+              <a:t>Rerankers</a:t>
+            </a:r>
+            <a:endParaRPr sz="2000" dirty="0"/>
           </a:p>
           <a:p>
             <a:pPr>
@@ -4296,9 +4510,21 @@
               </a:defRPr>
             </a:pPr>
             <a:r>
-              <a:t>Heavy cross-encoders or generative LLM rerankers introduce extreme latency and high memory requirements on edge/CPU hardware.</a:t>
-            </a:r>
-            <a:br/>
+              <a:rPr sz="2000" dirty="0"/>
+              <a:t>Heavy cross-encoders or generative LLM </a:t>
+            </a:r>
+            <a:r>
+              <a:rPr sz="2000" dirty="0" err="1"/>
+              <a:t>rerankers</a:t>
+            </a:r>
+            <a:r>
+              <a:rPr sz="2000" dirty="0"/>
+              <a:t> introduce extreme latency and high memory requirements on edge/CPU hardware.</a:t>
+            </a:r>
+            <a:br>
+              <a:rPr sz="2000" dirty="0"/>
+            </a:br>
+            <a:endParaRPr sz="2000" dirty="0"/>
           </a:p>
           <a:p>
             <a:pPr>
@@ -4309,6 +4535,7 @@
               </a:defRPr>
             </a:pPr>
             <a:r>
+              <a:rPr sz="2000" dirty="0"/>
               <a:t>4. Lack of Version-Aware Retrieval</a:t>
             </a:r>
           </a:p>
@@ -4321,9 +4548,13 @@
               </a:defRPr>
             </a:pPr>
             <a:r>
+              <a:rPr sz="2000" dirty="0"/>
               <a:t>Standard search indexes cannot isolate, tag, or retrieve code snippets corresponding to specific code versions or release branches.</a:t>
             </a:r>
-            <a:br/>
+            <a:br>
+              <a:rPr sz="2000" dirty="0"/>
+            </a:br>
+            <a:endParaRPr sz="2000" dirty="0"/>
           </a:p>
         </p:txBody>
       </p:sp>
@@ -4336,7 +4567,7 @@
 </file>
 
 <file path=ppt/slides/slide4.xml><?xml version="1.0" encoding="utf-8"?>
-<p:sld xmlns:a="http://schemas.openxmlformats.org/drawingml/2006/main" xmlns:p="http://schemas.openxmlformats.org/presentationml/2006/main" xmlns:r="http://schemas.openxmlformats.org/officeDocument/2006/relationships">
+<p:sld xmlns:a="http://schemas.openxmlformats.org/drawingml/2006/main" xmlns:r="http://schemas.openxmlformats.org/officeDocument/2006/relationships" xmlns:p="http://schemas.openxmlformats.org/presentationml/2006/main">
   <p:cSld>
     <p:spTree>
       <p:nvGrpSpPr>
@@ -4344,7 +4575,14 @@
         <p:cNvGrpSpPr/>
         <p:nvPr/>
       </p:nvGrpSpPr>
-      <p:grpSpPr/>
+      <p:grpSpPr>
+        <a:xfrm>
+          <a:off x="0" y="0"/>
+          <a:ext cx="0" cy="0"/>
+          <a:chOff x="0" y="0"/>
+          <a:chExt cx="0" cy="0"/>
+        </a:xfrm>
+      </p:grpSpPr>
       <p:sp>
         <p:nvSpPr>
           <p:cNvPr id="2" name="Rectangle 1"/>
@@ -4385,6 +4623,7 @@
           <a:lstStyle/>
           <a:p>
             <a:pPr algn="ctr"/>
+            <a:endParaRPr/>
           </a:p>
         </p:txBody>
       </p:sp>
@@ -4577,7 +4816,7 @@
 </file>
 
 <file path=ppt/slides/slide5.xml><?xml version="1.0" encoding="utf-8"?>
-<p:sld xmlns:a="http://schemas.openxmlformats.org/drawingml/2006/main" xmlns:p="http://schemas.openxmlformats.org/presentationml/2006/main" xmlns:r="http://schemas.openxmlformats.org/officeDocument/2006/relationships">
+<p:sld xmlns:a="http://schemas.openxmlformats.org/drawingml/2006/main" xmlns:r="http://schemas.openxmlformats.org/officeDocument/2006/relationships" xmlns:p="http://schemas.openxmlformats.org/presentationml/2006/main">
   <p:cSld>
     <p:spTree>
       <p:nvGrpSpPr>
@@ -4585,7 +4824,14 @@
         <p:cNvGrpSpPr/>
         <p:nvPr/>
       </p:nvGrpSpPr>
-      <p:grpSpPr/>
+      <p:grpSpPr>
+        <a:xfrm>
+          <a:off x="0" y="0"/>
+          <a:ext cx="0" cy="0"/>
+          <a:chOff x="0" y="0"/>
+          <a:chExt cx="0" cy="0"/>
+        </a:xfrm>
+      </p:grpSpPr>
       <p:sp>
         <p:nvSpPr>
           <p:cNvPr id="2" name="Rectangle 1"/>
@@ -4626,6 +4872,7 @@
           <a:lstStyle/>
           <a:p>
             <a:pPr algn="ctr"/>
+            <a:endParaRPr/>
           </a:p>
         </p:txBody>
       </p:sp>
@@ -4674,7 +4921,7 @@
         <p:spPr>
           <a:xfrm>
             <a:off x="731520" y="1371600"/>
-            <a:ext cx="10728655" cy="5029200"/>
+            <a:ext cx="10728655" cy="4832092"/>
           </a:xfrm>
           <a:prstGeom prst="rect">
             <a:avLst/>
@@ -4695,100 +4942,206 @@
               </a:defRPr>
             </a:pPr>
             <a:r>
+              <a:rPr sz="1400" dirty="0"/>
               <a:t>CLI Command Execution &amp; Live Retrieval Output</a:t>
             </a:r>
-          </a:p>
-          <a:p>
-            <a:pPr>
-              <a:defRPr sz="1100">
-                <a:solidFill>
-                  <a:srgbClr val="1E1E2D"/>
-                </a:solidFill>
-                <a:latin typeface="Consolas"/>
-              </a:defRPr>
-            </a:pPr>
-            <a:r>
-              <a:t>$ py -m src retrieve --query "Given an integer array nums, return true if any value appears at least twice"</a:t>
-            </a:r>
-            <a:br/>
-            <a:br/>
-            <a:r>
+            <a:br>
+              <a:rPr sz="1400" dirty="0"/>
+            </a:br>
+            <a:br>
+              <a:rPr sz="1400" dirty="0"/>
+            </a:br>
+            <a:r>
+              <a:rPr sz="1400" dirty="0"/>
               <a:t>============================================================</a:t>
             </a:r>
-            <a:br/>
-            <a:r>
+            <a:br>
+              <a:rPr sz="1400" dirty="0"/>
+            </a:br>
+            <a:r>
+              <a:rPr sz="1400" dirty="0"/>
               <a:t>AGENTIC CODE INTELLIGENCE - RETRIEVAL</a:t>
             </a:r>
-            <a:br/>
-            <a:r>
+            <a:br>
+              <a:rPr sz="1400" dirty="0"/>
+            </a:br>
+            <a:r>
+              <a:rPr sz="1400" dirty="0"/>
               <a:t>============================================================</a:t>
             </a:r>
-            <a:br/>
-            <a:r>
-              <a:t>Query: Given an integer array nums, return true if any value appears at least twice</a:t>
-            </a:r>
-            <a:br/>
-            <a:r>
+            <a:br>
+              <a:rPr sz="1400" dirty="0"/>
+            </a:br>
+            <a:r>
+              <a:rPr sz="1400" dirty="0"/>
+              <a:t>Query: Given an integer array </a:t>
+            </a:r>
+            <a:r>
+              <a:rPr sz="1400" dirty="0" err="1"/>
+              <a:t>nums</a:t>
+            </a:r>
+            <a:r>
+              <a:rPr sz="1400" dirty="0"/>
+              <a:t>, return true if any value appears at least twice</a:t>
+            </a:r>
+            <a:br>
+              <a:rPr sz="1400" dirty="0"/>
+            </a:br>
+            <a:r>
+              <a:rPr sz="1400" dirty="0"/>
               <a:t>Method: hybrid (FAISS + BM25 + Cross-Encoder Reranking)</a:t>
             </a:r>
-            <a:br/>
-            <a:r>
+            <a:br>
+              <a:rPr sz="1400" dirty="0"/>
+            </a:br>
+            <a:r>
+              <a:rPr sz="1400" dirty="0"/>
               <a:t>Top-K: 10 | Reranking: enabled</a:t>
             </a:r>
-            <a:br/>
-            <a:r>
+            <a:br>
+              <a:rPr sz="1400" dirty="0"/>
+            </a:br>
+            <a:r>
+              <a:rPr sz="1400" dirty="0"/>
               <a:t>------------------------------------------------------------</a:t>
             </a:r>
-            <a:br/>
-            <a:r>
+            <a:br>
+              <a:rPr sz="1400" dirty="0"/>
+            </a:br>
+            <a:r>
+              <a:rPr sz="1400" dirty="0"/>
               <a:t>RESULTS (retrieved in 9.952s total / &lt; 50ms index query time)</a:t>
             </a:r>
-            <a:br/>
-            <a:r>
+            <a:br>
+              <a:rPr sz="1400" dirty="0"/>
+            </a:br>
+            <a:r>
+              <a:rPr sz="1400" dirty="0"/>
               <a:t>============================================================</a:t>
             </a:r>
-            <a:br/>
-            <a:r>
+            <a:br>
+              <a:rPr sz="1400" dirty="0"/>
+            </a:br>
+            <a:r>
+              <a:rPr sz="1400" dirty="0"/>
               <a:t>  Rank 1 | Doc: d154 | Score: 0.031099</a:t>
             </a:r>
-            <a:br/>
-            <a:r>
+            <a:br>
+              <a:rPr sz="1400" dirty="0"/>
+            </a:br>
+            <a:r>
+              <a:rPr sz="1400" dirty="0"/>
               <a:t>  Code preview:</a:t>
             </a:r>
-            <a:br/>
-            <a:r>
+            <a:br>
+              <a:rPr sz="1400" dirty="0"/>
+            </a:br>
+            <a:r>
+              <a:rPr sz="1400" dirty="0"/>
               <a:t>    class Solution:</a:t>
             </a:r>
-            <a:br/>
-            <a:r>
-              <a:t>        def makesquare(self, nums):</a:t>
-            </a:r>
-            <a:br/>
-            <a:r>
-              <a:t>            """:type nums: List[int] :rtype: bool"""</a:t>
-            </a:r>
-            <a:br/>
-            <a:r>
+            <a:br>
+              <a:rPr sz="1400" dirty="0"/>
+            </a:br>
+            <a:r>
+              <a:rPr sz="1400" dirty="0"/>
+              <a:t>        def </a:t>
+            </a:r>
+            <a:r>
+              <a:rPr sz="1400" dirty="0" err="1"/>
+              <a:t>makesquare</a:t>
+            </a:r>
+            <a:r>
+              <a:rPr sz="1400" dirty="0"/>
+              <a:t>(self, </a:t>
+            </a:r>
+            <a:r>
+              <a:rPr sz="1400" dirty="0" err="1"/>
+              <a:t>nums</a:t>
+            </a:r>
+            <a:r>
+              <a:rPr sz="1400" dirty="0"/>
+              <a:t>):</a:t>
+            </a:r>
+            <a:br>
+              <a:rPr sz="1400" dirty="0"/>
+            </a:br>
+            <a:r>
+              <a:rPr sz="1400" dirty="0"/>
+              <a:t>            """:type </a:t>
+            </a:r>
+            <a:r>
+              <a:rPr sz="1400" dirty="0" err="1"/>
+              <a:t>nums</a:t>
+            </a:r>
+            <a:r>
+              <a:rPr sz="1400" dirty="0"/>
+              <a:t>: List[int] :</a:t>
+            </a:r>
+            <a:r>
+              <a:rPr sz="1400" dirty="0" err="1"/>
+              <a:t>rtype</a:t>
+            </a:r>
+            <a:r>
+              <a:rPr sz="1400" dirty="0"/>
+              <a:t>: bool"""</a:t>
+            </a:r>
+            <a:br>
+              <a:rPr sz="1400" dirty="0"/>
+            </a:br>
+            <a:r>
+              <a:rPr sz="1400" dirty="0"/>
               <a:t>  --------------------------------------------------</a:t>
             </a:r>
-            <a:br/>
-            <a:r>
+            <a:br>
+              <a:rPr sz="1400" dirty="0"/>
+            </a:br>
+            <a:r>
+              <a:rPr sz="1400" dirty="0"/>
               <a:t>  Rank 2 | Doc: d195 | Score: 0.030536</a:t>
             </a:r>
-            <a:br/>
-            <a:r>
+            <a:br>
+              <a:rPr sz="1400" dirty="0"/>
+            </a:br>
+            <a:r>
+              <a:rPr sz="1400" dirty="0"/>
               <a:t>  Code preview:</a:t>
             </a:r>
-            <a:br/>
-            <a:r>
+            <a:br>
+              <a:rPr sz="1400" dirty="0"/>
+            </a:br>
+            <a:r>
+              <a:rPr sz="1400" dirty="0"/>
               <a:t>    class Solution:</a:t>
             </a:r>
-            <a:br/>
-            <a:r>
-              <a:t>        def canPartitionKSubsets(self, nums, k):</a:t>
-            </a:r>
-            <a:br/>
-            <a:r>
+            <a:br>
+              <a:rPr sz="1400" dirty="0"/>
+            </a:br>
+            <a:r>
+              <a:rPr sz="1400" dirty="0"/>
+              <a:t>        def </a:t>
+            </a:r>
+            <a:r>
+              <a:rPr sz="1400" dirty="0" err="1"/>
+              <a:t>canPartitionKSubsets</a:t>
+            </a:r>
+            <a:r>
+              <a:rPr sz="1400" dirty="0"/>
+              <a:t>(self, </a:t>
+            </a:r>
+            <a:r>
+              <a:rPr sz="1400" dirty="0" err="1"/>
+              <a:t>nums</a:t>
+            </a:r>
+            <a:r>
+              <a:rPr sz="1400" dirty="0"/>
+              <a:t>, k):</a:t>
+            </a:r>
+            <a:br>
+              <a:rPr sz="1400" dirty="0"/>
+            </a:br>
+            <a:r>
+              <a:rPr sz="1400" dirty="0"/>
               <a:t>  --------------------------------------------------</a:t>
             </a:r>
           </a:p>
@@ -4803,7 +5156,7 @@
 </file>
 
 <file path=ppt/slides/slide6.xml><?xml version="1.0" encoding="utf-8"?>
-<p:sld xmlns:a="http://schemas.openxmlformats.org/drawingml/2006/main" xmlns:p="http://schemas.openxmlformats.org/presentationml/2006/main" xmlns:r="http://schemas.openxmlformats.org/officeDocument/2006/relationships">
+<p:sld xmlns:a="http://schemas.openxmlformats.org/drawingml/2006/main" xmlns:r="http://schemas.openxmlformats.org/officeDocument/2006/relationships" xmlns:p="http://schemas.openxmlformats.org/presentationml/2006/main">
   <p:cSld>
     <p:spTree>
       <p:nvGrpSpPr>
@@ -4811,7 +5164,14 @@
         <p:cNvGrpSpPr/>
         <p:nvPr/>
       </p:nvGrpSpPr>
-      <p:grpSpPr/>
+      <p:grpSpPr>
+        <a:xfrm>
+          <a:off x="0" y="0"/>
+          <a:ext cx="0" cy="0"/>
+          <a:chOff x="0" y="0"/>
+          <a:chExt cx="0" cy="0"/>
+        </a:xfrm>
+      </p:grpSpPr>
       <p:sp>
         <p:nvSpPr>
           <p:cNvPr id="2" name="Rectangle 1"/>
@@ -4852,6 +5212,7 @@
           <a:lstStyle/>
           <a:p>
             <a:pPr algn="ctr"/>
+            <a:endParaRPr/>
           </a:p>
         </p:txBody>
       </p:sp>
@@ -4900,7 +5261,7 @@
         <p:spPr>
           <a:xfrm>
             <a:off x="731520" y="1463040"/>
-            <a:ext cx="10728655" cy="4754880"/>
+            <a:ext cx="10728655" cy="3985706"/>
           </a:xfrm>
           <a:prstGeom prst="rect">
             <a:avLst/>
@@ -4921,15 +5282,32 @@
               </a:defRPr>
             </a:pPr>
             <a:r>
+              <a:rPr sz="2300" dirty="0"/>
               <a:t>• Core Language &amp; Environment: </a:t>
             </a:r>
             <a:r>
-              <a:rPr b="0">
+              <a:rPr sz="2300" b="0" dirty="0">
                 <a:solidFill>
                   <a:srgbClr val="1E1E2D"/>
                 </a:solidFill>
               </a:rPr>
-              <a:t>Python 3.10+ / PyTorch 2.14 / NumPy / SciPy</a:t>
+              <a:t>Python 3.10+ / </a:t>
+            </a:r>
+            <a:r>
+              <a:rPr sz="2300" b="0" dirty="0" err="1">
+                <a:solidFill>
+                  <a:srgbClr val="1E1E2D"/>
+                </a:solidFill>
+              </a:rPr>
+              <a:t>PyTorch</a:t>
+            </a:r>
+            <a:r>
+              <a:rPr sz="2300" b="0" dirty="0">
+                <a:solidFill>
+                  <a:srgbClr val="1E1E2D"/>
+                </a:solidFill>
+              </a:rPr>
+              <a:t> 2.14 / NumPy / SciPy</a:t>
             </a:r>
           </a:p>
           <a:p>
@@ -4941,15 +5319,32 @@
               </a:defRPr>
             </a:pPr>
             <a:r>
+              <a:rPr sz="2300" dirty="0"/>
               <a:t>• Vector Indexing &amp; Search Engine: </a:t>
             </a:r>
             <a:r>
-              <a:rPr b="0">
+              <a:rPr sz="2300" b="0" dirty="0">
                 <a:solidFill>
                   <a:srgbClr val="1E1E2D"/>
                 </a:solidFill>
               </a:rPr>
-              <a:t>FAISS (`faiss-cpu` 1.15) for high-performance dense vector inner-product search</a:t>
+              <a:t>FAISS (`</a:t>
+            </a:r>
+            <a:r>
+              <a:rPr sz="2300" b="0" dirty="0" err="1">
+                <a:solidFill>
+                  <a:srgbClr val="1E1E2D"/>
+                </a:solidFill>
+              </a:rPr>
+              <a:t>faiss-cpu</a:t>
+            </a:r>
+            <a:r>
+              <a:rPr sz="2300" b="0" dirty="0">
+                <a:solidFill>
+                  <a:srgbClr val="1E1E2D"/>
+                </a:solidFill>
+              </a:rPr>
+              <a:t>` 1.15) for high-performance dense vector inner-product search</a:t>
             </a:r>
           </a:p>
           <a:p>
@@ -4961,15 +5356,40 @@
               </a:defRPr>
             </a:pPr>
             <a:r>
+              <a:rPr sz="2300" dirty="0"/>
               <a:t>• Dense Embedding Models: </a:t>
             </a:r>
             <a:r>
-              <a:rPr b="0">
+              <a:rPr sz="2300" b="0" dirty="0" err="1">
                 <a:solidFill>
                   <a:srgbClr val="1E1E2D"/>
                 </a:solidFill>
               </a:rPr>
-              <a:t>SentenceTransformers (`BAAI/bge-small-en-v1.5` default, `jinaai/jina-embeddings-v2-base-code` optional)</a:t>
+              <a:t>SentenceTransformers</a:t>
+            </a:r>
+            <a:r>
+              <a:rPr sz="2300" b="0" dirty="0">
+                <a:solidFill>
+                  <a:srgbClr val="1E1E2D"/>
+                </a:solidFill>
+              </a:rPr>
+              <a:t> (`BAAI/bge-small-en-v1.5` default, `</a:t>
+            </a:r>
+            <a:r>
+              <a:rPr sz="2300" b="0" dirty="0" err="1">
+                <a:solidFill>
+                  <a:srgbClr val="1E1E2D"/>
+                </a:solidFill>
+              </a:rPr>
+              <a:t>jinaai</a:t>
+            </a:r>
+            <a:r>
+              <a:rPr sz="2300" b="0" dirty="0">
+                <a:solidFill>
+                  <a:srgbClr val="1E1E2D"/>
+                </a:solidFill>
+              </a:rPr>
+              <a:t>/jina-embeddings-v2-base-code` optional)</a:t>
             </a:r>
           </a:p>
           <a:p>
@@ -4981,16 +5401,30 @@
               </a:defRPr>
             </a:pPr>
             <a:r>
+              <a:rPr sz="2300" dirty="0"/>
               <a:t>• Lexical Retrieval &amp; Tokenization: </a:t>
             </a:r>
             <a:r>
-              <a:rPr b="0">
+              <a:rPr sz="2300" b="0" dirty="0">
                 <a:solidFill>
                   <a:srgbClr val="1E1E2D"/>
                 </a:solidFill>
               </a:rPr>
-              <a:t>`rank_bm25` (BM25Okapi) with regex identifier splitting for camelCase and snake_case</a:t>
-            </a:r>
+              <a:t>`rank_bm25` (BM25Okapi) with regex identifier splitting for camelCase and </a:t>
+            </a:r>
+            <a:r>
+              <a:rPr sz="2300" b="0" dirty="0" err="1">
+                <a:solidFill>
+                  <a:srgbClr val="1E1E2D"/>
+                </a:solidFill>
+              </a:rPr>
+              <a:t>snake_case</a:t>
+            </a:r>
+            <a:endParaRPr sz="2300" b="0" dirty="0">
+              <a:solidFill>
+                <a:srgbClr val="1E1E2D"/>
+              </a:solidFill>
+            </a:endParaRPr>
           </a:p>
           <a:p>
             <a:pPr>
@@ -5001,10 +5435,11 @@
               </a:defRPr>
             </a:pPr>
             <a:r>
+              <a:rPr sz="2300" dirty="0"/>
               <a:t>• Cross-Encoder Reranking: </a:t>
             </a:r>
             <a:r>
-              <a:rPr b="0">
+              <a:rPr sz="2300" b="0" dirty="0">
                 <a:solidFill>
                   <a:srgbClr val="1E1E2D"/>
                 </a:solidFill>
@@ -5021,15 +5456,48 @@
               </a:defRPr>
             </a:pPr>
             <a:r>
+              <a:rPr sz="2300" dirty="0"/>
               <a:t>• Benchmark &amp; Evaluation Framework: </a:t>
             </a:r>
             <a:r>
-              <a:rPr b="0">
+              <a:rPr sz="2300" b="0" dirty="0">
                 <a:solidFill>
                   <a:srgbClr val="1E1E2D"/>
                 </a:solidFill>
               </a:rPr>
-              <a:t>Official MTEB framework (`mteb` 2.21.8) &amp; HuggingFace `datasets`</a:t>
+              <a:t>Official MTEB framework (`</a:t>
+            </a:r>
+            <a:r>
+              <a:rPr sz="2300" b="0" dirty="0" err="1">
+                <a:solidFill>
+                  <a:srgbClr val="1E1E2D"/>
+                </a:solidFill>
+              </a:rPr>
+              <a:t>mteb</a:t>
+            </a:r>
+            <a:r>
+              <a:rPr sz="2300" b="0" dirty="0">
+                <a:solidFill>
+                  <a:srgbClr val="1E1E2D"/>
+                </a:solidFill>
+              </a:rPr>
+              <a:t>` 2.21.8) &amp; </a:t>
+            </a:r>
+            <a:r>
+              <a:rPr sz="2300" b="0" dirty="0" err="1">
+                <a:solidFill>
+                  <a:srgbClr val="1E1E2D"/>
+                </a:solidFill>
+              </a:rPr>
+              <a:t>HuggingFace</a:t>
+            </a:r>
+            <a:r>
+              <a:rPr sz="2300" b="0" dirty="0">
+                <a:solidFill>
+                  <a:srgbClr val="1E1E2D"/>
+                </a:solidFill>
+              </a:rPr>
+              <a:t> `datasets`</a:t>
             </a:r>
           </a:p>
         </p:txBody>
@@ -5043,7 +5511,7 @@
 </file>
 
 <file path=ppt/slides/slide7.xml><?xml version="1.0" encoding="utf-8"?>
-<p:sld xmlns:a="http://schemas.openxmlformats.org/drawingml/2006/main" xmlns:p="http://schemas.openxmlformats.org/presentationml/2006/main" xmlns:r="http://schemas.openxmlformats.org/officeDocument/2006/relationships">
+<p:sld xmlns:a="http://schemas.openxmlformats.org/drawingml/2006/main" xmlns:r="http://schemas.openxmlformats.org/officeDocument/2006/relationships" xmlns:p="http://schemas.openxmlformats.org/presentationml/2006/main">
   <p:cSld>
     <p:spTree>
       <p:nvGrpSpPr>
@@ -5051,7 +5519,14 @@
         <p:cNvGrpSpPr/>
         <p:nvPr/>
       </p:nvGrpSpPr>
-      <p:grpSpPr/>
+      <p:grpSpPr>
+        <a:xfrm>
+          <a:off x="0" y="0"/>
+          <a:ext cx="0" cy="0"/>
+          <a:chOff x="0" y="0"/>
+          <a:chExt cx="0" cy="0"/>
+        </a:xfrm>
+      </p:grpSpPr>
       <p:sp>
         <p:nvSpPr>
           <p:cNvPr id="2" name="Rectangle 1"/>
@@ -5092,6 +5567,7 @@
           <a:lstStyle/>
           <a:p>
             <a:pPr algn="ctr"/>
+            <a:endParaRPr/>
           </a:p>
         </p:txBody>
       </p:sp>
@@ -5140,7 +5616,7 @@
         <p:spPr>
           <a:xfrm>
             <a:off x="731520" y="1463040"/>
-            <a:ext cx="10728655" cy="4754880"/>
+            <a:ext cx="10728655" cy="5016758"/>
           </a:xfrm>
           <a:prstGeom prst="rect">
             <a:avLst/>
@@ -5161,6 +5637,7 @@
               </a:defRPr>
             </a:pPr>
             <a:r>
+              <a:rPr sz="2000" dirty="0"/>
               <a:t>1. Enterprise Developer Productivity</a:t>
             </a:r>
           </a:p>
@@ -5173,9 +5650,13 @@
               </a:defRPr>
             </a:pPr>
             <a:r>
+              <a:rPr sz="2000" dirty="0"/>
               <a:t>Enables natural-language search over multi-million-line proprietary codebases, reducing time spent searching for legacy functions.</a:t>
             </a:r>
-            <a:br/>
+            <a:br>
+              <a:rPr sz="2000" dirty="0"/>
+            </a:br>
+            <a:endParaRPr sz="2000" dirty="0"/>
           </a:p>
           <a:p>
             <a:pPr>
@@ -5186,6 +5667,7 @@
               </a:defRPr>
             </a:pPr>
             <a:r>
+              <a:rPr sz="2000" dirty="0"/>
               <a:t>2. AI Coding Assistants &amp; Agentic Retrieval</a:t>
             </a:r>
           </a:p>
@@ -5198,9 +5680,13 @@
               </a:defRPr>
             </a:pPr>
             <a:r>
+              <a:rPr sz="2000" dirty="0"/>
               <a:t>Provides low-latency context retrieval for agentic coding assistants (e.g. Copilot, Gemini) to fetch relevant code context.</a:t>
             </a:r>
-            <a:br/>
+            <a:br>
+              <a:rPr sz="2000" dirty="0"/>
+            </a:br>
+            <a:endParaRPr sz="2000" dirty="0"/>
           </a:p>
           <a:p>
             <a:pPr>
@@ -5211,6 +5697,7 @@
               </a:defRPr>
             </a:pPr>
             <a:r>
+              <a:rPr sz="2000" dirty="0"/>
               <a:t>3. Competitive Programming &amp; Education</a:t>
             </a:r>
           </a:p>
@@ -5223,9 +5710,13 @@
               </a:defRPr>
             </a:pPr>
             <a:r>
+              <a:rPr sz="2000" dirty="0"/>
               <a:t>Allows students and competitive programmers to query problem requirements and retrieve exact algorithmic implementations.</a:t>
             </a:r>
-            <a:br/>
+            <a:br>
+              <a:rPr sz="2000" dirty="0"/>
+            </a:br>
+            <a:endParaRPr sz="2000" dirty="0"/>
           </a:p>
           <a:p>
             <a:pPr>
@@ -5236,6 +5727,7 @@
               </a:defRPr>
             </a:pPr>
             <a:r>
+              <a:rPr sz="2000" dirty="0"/>
               <a:t>4. Edge &amp; CPU Infrastructure Efficiency</a:t>
             </a:r>
           </a:p>
@@ -5248,9 +5740,13 @@
               </a:defRPr>
             </a:pPr>
             <a:r>
+              <a:rPr sz="2000" dirty="0"/>
               <a:t>Lightweight design runs entirely on standard CPUs without requiring expensive GPU server infrastructure.</a:t>
             </a:r>
-            <a:br/>
+            <a:br>
+              <a:rPr sz="2000" dirty="0"/>
+            </a:br>
+            <a:endParaRPr sz="2000" dirty="0"/>
           </a:p>
         </p:txBody>
       </p:sp>
@@ -5263,7 +5759,7 @@
 </file>
 
 <file path=ppt/slides/slide8.xml><?xml version="1.0" encoding="utf-8"?>
-<p:sld xmlns:a="http://schemas.openxmlformats.org/drawingml/2006/main" xmlns:p="http://schemas.openxmlformats.org/presentationml/2006/main" xmlns:r="http://schemas.openxmlformats.org/officeDocument/2006/relationships">
+<p:sld xmlns:a="http://schemas.openxmlformats.org/drawingml/2006/main" xmlns:r="http://schemas.openxmlformats.org/officeDocument/2006/relationships" xmlns:p="http://schemas.openxmlformats.org/presentationml/2006/main">
   <p:cSld>
     <p:spTree>
       <p:nvGrpSpPr>
@@ -5271,7 +5767,14 @@
         <p:cNvGrpSpPr/>
         <p:nvPr/>
       </p:nvGrpSpPr>
-      <p:grpSpPr/>
+      <p:grpSpPr>
+        <a:xfrm>
+          <a:off x="0" y="0"/>
+          <a:ext cx="0" cy="0"/>
+          <a:chOff x="0" y="0"/>
+          <a:chExt cx="0" cy="0"/>
+        </a:xfrm>
+      </p:grpSpPr>
       <p:sp>
         <p:nvSpPr>
           <p:cNvPr id="2" name="Rectangle 1"/>
@@ -5312,6 +5815,7 @@
           <a:lstStyle/>
           <a:p>
             <a:pPr algn="ctr"/>
+            <a:endParaRPr/>
           </a:p>
         </p:txBody>
       </p:sp>
@@ -5360,7 +5864,7 @@
         <p:spPr>
           <a:xfrm>
             <a:off x="731520" y="1463040"/>
-            <a:ext cx="10728655" cy="4754880"/>
+            <a:ext cx="10728655" cy="3416320"/>
           </a:xfrm>
           <a:prstGeom prst="rect">
             <a:avLst/>
@@ -5381,6 +5885,7 @@
               </a:defRPr>
             </a:pPr>
             <a:r>
+              <a:rPr sz="2400" dirty="0"/>
               <a:t>Innovation Highlights &amp; Actual Benchmark Results</a:t>
             </a:r>
           </a:p>
@@ -5393,18 +5898,36 @@
               </a:defRPr>
             </a:pPr>
             <a:r>
+              <a:rPr sz="2400" dirty="0"/>
               <a:t>• Innovations: Reciprocal Rank Fusion (RRF) + Code-Aware Tokenization + Version-Aware Index Management.</a:t>
             </a:r>
-            <a:br/>
-            <a:r>
-              <a:t>• Official MTEB AppsRetrieval Scores: NDCG@10 = 0.0514 | MRR@10 = 0.0437 | Recall@10 = 0.0765 | MAP@10 = 0.0437</a:t>
-            </a:r>
-            <a:br/>
-            <a:r>
+            <a:br>
+              <a:rPr sz="2400" dirty="0"/>
+            </a:br>
+            <a:r>
+              <a:rPr sz="2400" dirty="0"/>
+              <a:t>• Official MTEB </a:t>
+            </a:r>
+            <a:r>
+              <a:rPr sz="2400" dirty="0" err="1"/>
+              <a:t>AppsRetrieval</a:t>
+            </a:r>
+            <a:r>
+              <a:rPr sz="2400" dirty="0"/>
+              <a:t> Scores: NDCG@10 = 0.0514 | MRR@10 = 0.0437 | Recall@10 = 0.0765 | MAP@10 = 0.0437</a:t>
+            </a:r>
+            <a:br>
+              <a:rPr sz="2400" dirty="0"/>
+            </a:br>
+            <a:r>
+              <a:rPr sz="2400" dirty="0"/>
               <a:t>• Method Comparison (Test Split): Hybrid RRF achieves NDCG@10 = 0.0718 &amp; Recall@10 = 0.1100 (outperforming Lexical 0.0163 &amp; Dense 0.0632).</a:t>
             </a:r>
-            <a:br/>
-            <a:r>
+            <a:br>
+              <a:rPr sz="2400" dirty="0"/>
+            </a:br>
+            <a:r>
+              <a:rPr sz="2400" dirty="0"/>
               <a:t>• Limitations: Current tokenizer rules optimized for Python syntax; multi-language AST parsing (Java/C++) is planned.</a:t>
             </a:r>
           </a:p>
@@ -5419,7 +5942,7 @@
 </file>
 
 <file path=ppt/slides/slide9.xml><?xml version="1.0" encoding="utf-8"?>
-<p:sld xmlns:a="http://schemas.openxmlformats.org/drawingml/2006/main" xmlns:p="http://schemas.openxmlformats.org/presentationml/2006/main" xmlns:r="http://schemas.openxmlformats.org/officeDocument/2006/relationships">
+<p:sld xmlns:a="http://schemas.openxmlformats.org/drawingml/2006/main" xmlns:r="http://schemas.openxmlformats.org/officeDocument/2006/relationships" xmlns:p="http://schemas.openxmlformats.org/presentationml/2006/main">
   <p:cSld>
     <p:spTree>
       <p:nvGrpSpPr>
@@ -5427,7 +5950,14 @@
         <p:cNvGrpSpPr/>
         <p:nvPr/>
       </p:nvGrpSpPr>
-      <p:grpSpPr/>
+      <p:grpSpPr>
+        <a:xfrm>
+          <a:off x="0" y="0"/>
+          <a:ext cx="0" cy="0"/>
+          <a:chOff x="0" y="0"/>
+          <a:chExt cx="0" cy="0"/>
+        </a:xfrm>
+      </p:grpSpPr>
       <p:sp>
         <p:nvSpPr>
           <p:cNvPr id="2" name="Rectangle 1"/>
@@ -5468,6 +5998,7 @@
           <a:lstStyle/>
           <a:p>
             <a:pPr algn="ctr"/>
+            <a:endParaRPr/>
           </a:p>
         </p:txBody>
       </p:sp>
@@ -5516,7 +6047,7 @@
         <p:spPr>
           <a:xfrm>
             <a:off x="731520" y="1463040"/>
-            <a:ext cx="10728655" cy="4754880"/>
+            <a:ext cx="10728655" cy="4093428"/>
           </a:xfrm>
           <a:prstGeom prst="rect">
             <a:avLst/>
@@ -5537,6 +6068,7 @@
               </a:defRPr>
             </a:pPr>
             <a:r>
+              <a:rPr sz="2000" dirty="0"/>
               <a:t>• AST-Level Graph Parsing (Tree-Sitter)</a:t>
             </a:r>
           </a:p>
@@ -5549,9 +6081,13 @@
               </a:defRPr>
             </a:pPr>
             <a:r>
+              <a:rPr sz="2000" dirty="0"/>
               <a:t>  Integrate Abstract Syntax Tree (AST) parsing to index code structural graphs alongside text tokens.</a:t>
             </a:r>
-            <a:br/>
+            <a:br>
+              <a:rPr sz="2000" dirty="0"/>
+            </a:br>
+            <a:endParaRPr sz="2000" dirty="0"/>
           </a:p>
           <a:p>
             <a:pPr>
@@ -5562,6 +6098,7 @@
               </a:defRPr>
             </a:pPr>
             <a:r>
+              <a:rPr sz="2000" dirty="0"/>
               <a:t>• Multi-Language Expansion</a:t>
             </a:r>
           </a:p>
@@ -5574,9 +6111,13 @@
               </a:defRPr>
             </a:pPr>
             <a:r>
+              <a:rPr sz="2000" dirty="0"/>
               <a:t>  Extend specialized preprocessors for C++, Java, Rust, Go, and TypeScript syntax.</a:t>
             </a:r>
-            <a:br/>
+            <a:br>
+              <a:rPr sz="2000" dirty="0"/>
+            </a:br>
+            <a:endParaRPr sz="2000" dirty="0"/>
           </a:p>
           <a:p>
             <a:pPr>
@@ -5587,6 +6128,7 @@
               </a:defRPr>
             </a:pPr>
             <a:r>
+              <a:rPr sz="2000" dirty="0"/>
               <a:t>• On-Device Embedding Quantization</a:t>
             </a:r>
           </a:p>
@@ -5599,9 +6141,13 @@
               </a:defRPr>
             </a:pPr>
             <a:r>
+              <a:rPr sz="2000" dirty="0"/>
               <a:t>  Apply INT8 quantization to vector embeddings to reduce index memory footprint by 4x for mobile/local IDE deployment.</a:t>
             </a:r>
-            <a:br/>
+            <a:br>
+              <a:rPr sz="2000" dirty="0"/>
+            </a:br>
+            <a:endParaRPr sz="2000" dirty="0"/>
           </a:p>
           <a:p>
             <a:pPr>
@@ -5612,7 +6158,16 @@
               </a:defRPr>
             </a:pPr>
             <a:r>
-              <a:t>• IDE Plugins (VSCode &amp; JetBrains)</a:t>
+              <a:rPr sz="2000" dirty="0"/>
+              <a:t>• IDE Plugins (</a:t>
+            </a:r>
+            <a:r>
+              <a:rPr sz="2000" dirty="0" err="1"/>
+              <a:t>VSCode</a:t>
+            </a:r>
+            <a:r>
+              <a:rPr sz="2000" dirty="0"/>
+              <a:t> &amp; JetBrains)</a:t>
             </a:r>
           </a:p>
           <a:p>
@@ -5624,9 +6179,13 @@
               </a:defRPr>
             </a:pPr>
             <a:r>
+              <a:rPr sz="2000" dirty="0"/>
               <a:t>  Package the retrieval engine into native IDE extensions for seamless developer workflows.</a:t>
             </a:r>
-            <a:br/>
+            <a:br>
+              <a:rPr sz="2000" dirty="0"/>
+            </a:br>
+            <a:endParaRPr sz="2000" dirty="0"/>
           </a:p>
         </p:txBody>
       </p:sp>

</xml_diff>